<commit_message>
Add English speaker scripts to PCAP slides
</commit_message>
<xml_diff>
--- a/docs/slides/eng/20261030_PCAP_Research_Direction.pptx
+++ b/docs/slides/eng/20261030_PCAP_Research_Direction.pptx
@@ -507,18 +507,18 @@
           <a:lstStyle/>
           <a:p>
             <a:r>
-              <a:t>발표 설명</a:t>
-            </a:r>
-          </a:p>
-          <a:p>
-            <a:r>
-              <a:t>Prior XGB, TabPFN, SOTA, and proposed-model experiments used CICFlowMeter CSV vectors as classification inputs. Many IDS tabular-classification studies also trained and evaluated with the supplied flow statistics. The right half shows how CIC-IDS2017 produced this CSV: network traffic was captured as PCAP, then CICFlowMeter grouped packets into flows and calculated duration, packet-count, IAT, and flag statistics. A CSV row is a summary of these fixed statistics, not the packet sequence itself.</a:t>
+              <a:t>Speaker notes</a:t>
+            </a:r>
+          </a:p>
+          <a:p>
+            <a:r>
+              <a:t>I will begin with the input that has been used throughout our IDS experiments. CIC datasets first record network traffic as PCAP files. CICFlowMeter then groups packets into flows and writes one CSV row per flow using fixed statistics such as duration, packet counts, packet lengths, inter-arrival times, and TCP flags. Our previous XGB, TabPFN, SOTA, and proposed-model experiments all used these CSV vectors, as do many IDS studies that frame the task as tabular classification. The important point is that a row is a predefined statistical summary. It does not retain the full order of packets that generated the flow. The following observations therefore concern both the classifiers and this shared input representation.</a:t>
             </a:r>
           </a:p>
           <a:p/>
           <a:p>
             <a:r>
-              <a:t>원문 근거</a:t>
+              <a:t>Sources</a:t>
             </a:r>
           </a:p>
           <a:p>
@@ -608,21 +608,14 @@
           <a:lstStyle/>
           <a:p>
             <a:r>
-              <a:t>발표 설명</a:t>
-            </a:r>
-          </a:p>
-          <a:p>
-            <a:r>
-              <a:t>The CSV-based evaluation revealed two issues. First, some head attacks retained high F1 even after their label budget was reduced sharply, so the representation and task difficulty should be checked before collecting more labels. Second, some rows had identical flow statistics but different labels. This does not mean that every label is wrong; it means that the current statistical representation cannot let a deterministic classifier predict both labels correctly. The next two slides show the observations through performance curves and literal source-CSV rows.</a:t>
-            </a:r>
-          </a:p>
-          <a:p/>
-          <a:p>
-            <a:r>
-              <a:t>원문 근거</a:t>
-            </a:r>
-          </a:p>
-          <a:p/>
+              <a:t>Speaker notes</a:t>
+            </a:r>
+          </a:p>
+          <a:p>
+            <a:r>
+              <a:t>When we inspected the CSV-based experiments, two patterns required separate attention. First, some head attack classes reached very high F1 with only a small label budget. Second, the raw CSV contained rows whose flow statistics were identical even though their recorded classes differed. These patterns affect how classification scores should be interpreted. The next slide quantifies the first pattern across label budgets, and the slide after that shows literal source-CSV rows for the second pattern.</a:t>
+            </a:r>
+          </a:p>
         </p:txBody>
       </p:sp>
       <p:sp>
@@ -690,21 +683,14 @@
           <a:lstStyle/>
           <a:p>
             <a:r>
-              <a:t>발표 설명</a:t>
-            </a:r>
-          </a:p>
-          <a:p>
-            <a:r>
-              <a:t>This figure extends the earlier CSV-based EXP87 attack-only condition from n = 2 to n = 450. Macro F1 still rises after n = 20, so the entire dataset is not fully saturated. However, head classes such as DDoS and Bot already reach high F1 around n = 20 and change little relative to n = 450. Web attacks remain low even with a larger label budget. Thus, the high average does not mean that every attack is easy: early head saturation and residual tail errors must be examined separately. This is a diagnostic of attack-to-attack classification, not IDS detection with benign traffic included.</a:t>
-            </a:r>
-          </a:p>
-          <a:p/>
-          <a:p>
-            <a:r>
-              <a:t>원문 근거</a:t>
-            </a:r>
-          </a:p>
-          <a:p/>
+              <a:t>Speaker notes</a:t>
+            </a:r>
+          </a:p>
+          <a:p>
+            <a:r>
+              <a:t>This figure is a diagnostic learning curve for attack-only classification. At n equals 20 labels per class, XGB reached F1 of 99.3 for DDoS, 98.6 for Bot, 96.7 for DoS, and 99.9 for BF. TabPFN reached 99.7 for DDoS, 99.4 for Bot, 96.1 for DoS, and 100.0 for BF under the same condition. Infiltration remained around 78 to 79, and web attacks remained around 9 to 11. The curve shows that adding labels still changes macro F1, but four classes are already close to saturation at n equals 20 while difficult classes remain difficult. This classwise imbalance motivates checking the data representation before drawing conclusions from an aggregate score.</a:t>
+            </a:r>
+          </a:p>
         </p:txBody>
       </p:sp>
       <p:sp>
@@ -772,18 +758,18 @@
           <a:lstStyle/>
           <a:p>
             <a:r>
-              <a:t>발표 설명</a:t>
-            </a:r>
-          </a:p>
-          <a:p>
-            <a:r>
-              <a:t>This slide audits the ten original CIC2018 CICFlowMeter CSV files, rather than an NF-v3-derived input. Rows were grouped when all 78 statistical fields common to every file agreed after excluding timestamps and flow identifiers. The table shows literal source-CSV values: displayed fields and the omitted 69 fields are identical, but the NF-v3 class differs. The bars retain the order benign, ddos, bot, dos, bf, inf, web. Their length and endpoint show the share and number of rows from each class in identical-feature, different-class groups. These values do not imply a single cause or that every label is wrong; they show why the representation and label-generation evidence must be examined together.</a:t>
+              <a:t>Speaker notes</a:t>
+            </a:r>
+          </a:p>
+          <a:p>
+            <a:r>
+              <a:t>Next, we inspected the original CIC2018 CSV files directly. We grouped rows whose 78 common CICFlowMeter statistics were exactly identical after excluding Timestamp, Flow ID, source IP and port, destination IP, and Label. The two rows at the top are a literal example: every displayed value and the omitted 69 fields agree, but their NF-v3 classes are dos and bf. Across all 16.23 million rows, 406,811 rows, or 2.51 percent, belong to identical-feature groups that span multiple NF-v3 classes. The incidence is particularly large for bf at 42.7 percent, followed by inf at 25.5 percent and dos at 11.8 percent. A classifier receives the same input for these cases, so the representation and the evidence used to assign labels must be examined together.</a:t>
             </a:r>
           </a:p>
           <a:p/>
           <a:p>
             <a:r>
-              <a:t>원문 근거</a:t>
+              <a:t>Sources</a:t>
             </a:r>
           </a:p>
           <a:p>
@@ -894,18 +880,18 @@
           <a:lstStyle/>
           <a:p>
             <a:r>
-              <a:t>발표 설명</a:t>
-            </a:r>
-          </a:p>
-          <a:p>
-            <a:r>
-              <a:t>CICFlowMeter calculates CSV features using pre-specified flow rules and statistics. The new pipeline preserves PCAP, time, and label linkage while a packet-sequence encoder generates embeddings and PCA is fit only on the training split. The encoder interface is interchangeable, so netFound, ET-BERT, and NetMamba can be compared with the same inputs, split, and evaluation. Each new vector space is first audited for identical embeddings with different labels and for PCAP label evidence. XGB and TabPFN baselines, few-shot learning curves, and classwise F1 then test whether early head saturation persists in the new representation.</a:t>
+              <a:t>Speaker notes</a:t>
+            </a:r>
+          </a:p>
+          <a:p>
+            <a:r>
+              <a:t>The next step is to build a new CIC2018 feature representation from the raw PCAP files. We preserve the link among each flow, its packets, its label evidence, and its train or test split. A network encoder then reads packet direction, size, timing, protocol, and header patterns and produces one vector per flow. NetFound is the first encoder in this pipeline. It is a pretrained network-data encoder; in this study it serves only to generate a 512-dimensional flow representation, which is projected to 64 dimensions using PCA fit on the training split. NetFound does not produce the attack label here. XGB and TabPFN receive its output vectors and perform the classification. The same corpus and split can later be reused with ET-BERT or NetMamba, so encoder choice can be evaluated under matched conditions.</a:t>
             </a:r>
           </a:p>
           <a:p/>
           <a:p>
             <a:r>
-              <a:t>원문 근거</a:t>
+              <a:t>Sources</a:t>
             </a:r>
           </a:p>
           <a:p>
@@ -1037,21 +1023,14 @@
           <a:lstStyle/>
           <a:p>
             <a:r>
-              <a:t>발표 설명</a:t>
-            </a:r>
-          </a:p>
-          <a:p>
-            <a:r>
-              <a:t>The presentation has three steps. Existing IDS classifiers used fixed CICFlowMeter statistics from CSV inputs. Inspection of those inputs identified early saturation for some head attacks and identical-feature, different-class rows in the original CSV. The next step is to measure both phenomena again on new CIC2018 vectors created by PCAP encoders, using the same audit and baseline protocol. Only after verifying whether the representation reduces conflicts and improves separation of tail or emerging attacks can a classification benefit from the new representation or model design be assessed.</a:t>
-            </a:r>
-          </a:p>
-          <a:p/>
-          <a:p>
-            <a:r>
-              <a:t>원문 근거</a:t>
-            </a:r>
-          </a:p>
-          <a:p/>
+              <a:t>Speaker notes</a:t>
+            </a:r>
+          </a:p>
+          <a:p>
+            <a:r>
+              <a:t>This presentation establishes the reason for rebuilding the input representation. The CSV experiments revealed early saturation for several head classes and exact feature conflicts across recorded classes in the original data. The PCAP pipeline creates a reusable corpus and encoder-specific vector views while keeping labels and splits traceable. The next evaluation will first repeat the representation audit, then rerun XGB and TabPFN baselines and few-shot curves on the new vectors. These checks will show whether the new representation changes the feature conflicts and classwise learning behavior observed in the current CSV experiments.</a:t>
+            </a:r>
+          </a:p>
         </p:txBody>
       </p:sp>
       <p:sp>
@@ -7631,7 +7610,7 @@
         <p:spPr>
           <a:xfrm>
             <a:off x="594360" y="1005840"/>
-            <a:ext cx="10972800" cy="249301"/>
+            <a:ext cx="10972800" cy="229819"/>
           </a:xfrm>
           <a:prstGeom prst="rect">
             <a:avLst/>
@@ -7657,7 +7636,7 @@
               </a:spcAft>
             </a:pPr>
             <a:r>
-              <a:rPr sz="1450" b="0" lang="ko-KR">
+              <a:rPr sz="1320" b="0" lang="ko-KR">
                 <a:solidFill>
                   <a:srgbClr val="617080"/>
                 </a:solidFill>
@@ -7665,7 +7644,7 @@
                 <a:ea typeface="Pretendard"/>
                 <a:cs typeface="Pretendard"/>
               </a:rPr>
-              <a:t>Exact agreement on 78 common CICFlowMeter statistics, excluding timestamps, identifiers, addresses, ports, and labels</a:t>
+              <a:t>Exact agreement on 78 common CICFlowMeter statistics, excluding timestamp, Flow ID, source IP/port, destination IP, and label</a:t>
             </a:r>
           </a:p>
         </p:txBody>

</xml_diff>